<commit_message>
Add Florian project docs and diagrams
Add multiple project deliverables and assets under Florian/ and partie commune/: several Cahier De Recette DOCX/PDF files, a structural diagram PNG, DualSenseX-Setup.zip, temporary Word file, and a use-case diagram PNG. Also add a .pptx.ppsx variant and update 'Partie commune.ppsx', 'Partie commune.pptx' and 'REVUE DE PROJET N°2.mvdx'. These changes add documentation, presentation assets and a setup archive for the InfoProd project.
</commit_message>
<xml_diff>
--- a/Florian/Partie commune.pptx
+++ b/Florian/Partie commune.pptx
@@ -1,38 +1,31 @@
 
 <file path=ppt/presentation.xml><?xml version="1.0" encoding="utf-8"?>
-<p:presentation xmlns:a="http://schemas.openxmlformats.org/drawingml/2006/main" xmlns:r="http://schemas.openxmlformats.org/officeDocument/2006/relationships" xmlns:p="http://schemas.openxmlformats.org/presentationml/2006/main" embedTrueTypeFonts="1" saveSubsetFonts="1">
+<p:presentation xmlns:a="http://schemas.openxmlformats.org/drawingml/2006/main" xmlns:r="http://schemas.openxmlformats.org/officeDocument/2006/relationships" xmlns:p="http://schemas.openxmlformats.org/presentationml/2006/main" saveSubsetFonts="1" embedTrueTypeFonts="true">
   <p:sldMasterIdLst>
     <p:sldMasterId id="2147483648" r:id="rId1"/>
   </p:sldMasterIdLst>
   <p:sldIdLst>
-    <p:sldId id="256" r:id="rId2"/>
-    <p:sldId id="257" r:id="rId3"/>
-    <p:sldId id="258" r:id="rId4"/>
-    <p:sldId id="259" r:id="rId5"/>
-    <p:sldId id="260" r:id="rId6"/>
-    <p:sldId id="261" r:id="rId7"/>
-    <p:sldId id="262" r:id="rId8"/>
+    <p:sldId id="256" r:id="rId6"/>
+    <p:sldId id="257" r:id="rId7"/>
+    <p:sldId id="258" r:id="rId8"/>
+    <p:sldId id="259" r:id="rId9"/>
+    <p:sldId id="260" r:id="rId10"/>
+    <p:sldId id="261" r:id="rId11"/>
+    <p:sldId id="262" r:id="rId12"/>
   </p:sldIdLst>
   <p:sldSz cx="18288000" cy="10287000"/>
   <p:notesSz cx="6858000" cy="9144000"/>
   <p:embeddedFontLst>
     <p:embeddedFont>
-      <p:font typeface="29LT Riwaya" panose="020B0604020202020204" charset="-78"/>
-      <p:regular r:id="rId9"/>
+      <p:font typeface="Boston Angel" charset="1" panose="00000000000000000000"/>
+      <p:regular r:id="rId13"/>
     </p:embeddedFont>
     <p:embeddedFont>
-      <p:font typeface="Boston Angel" panose="020B0604020202020204" charset="0"/>
-      <p:regular r:id="rId10"/>
+      <p:font typeface="29LT Riwaya" charset="1" panose="00000500000000000000"/>
+      <p:regular r:id="rId14"/>
     </p:embeddedFont>
     <p:embeddedFont>
-      <p:font typeface="Calibri" panose="020F0502020204030204" pitchFamily="34" charset="0"/>
-      <p:regular r:id="rId11"/>
-      <p:bold r:id="rId12"/>
-      <p:italic r:id="rId13"/>
-      <p:boldItalic r:id="rId14"/>
-    </p:embeddedFont>
-    <p:embeddedFont>
-      <p:font typeface="Open Sans" panose="020B0606030504020204" pitchFamily="34" charset="0"/>
+      <p:font typeface="Open Sans" charset="1" panose="020B0606030504020204"/>
       <p:regular r:id="rId15"/>
     </p:embeddedFont>
   </p:embeddedFontLst>
@@ -131,22 +124,6 @@
       </a:defRPr>
     </a:lvl9pPr>
   </p:defaultTextStyle>
-  <p:extLst>
-    <p:ext uri="{EFAFB233-063F-42B5-8137-9DF3F51BA10A}">
-      <p15:sldGuideLst xmlns:p15="http://schemas.microsoft.com/office/powerpoint/2012/main">
-        <p15:guide id="1" orient="horz" pos="2160">
-          <p15:clr>
-            <a:srgbClr val="A4A3A4"/>
-          </p15:clr>
-        </p15:guide>
-        <p15:guide id="2" pos="2880">
-          <p15:clr>
-            <a:srgbClr val="A4A3A4"/>
-          </p15:clr>
-        </p15:guide>
-      </p15:sldGuideLst>
-    </p:ext>
-  </p:extLst>
 </p:presentation>
 </file>
 
@@ -188,9 +165,10 @@
           <a:lstStyle/>
           <a:p>
             <a:r>
-              <a:rPr lang="en-US"/>
+              <a:rPr lang="en-US" smtClean="0"/>
               <a:t>Click to edit Master title style</a:t>
             </a:r>
+            <a:endParaRPr lang="en-US"/>
           </a:p>
         </p:txBody>
       </p:sp>
@@ -306,9 +284,10 @@
           </a:lstStyle>
           <a:p>
             <a:r>
-              <a:rPr lang="en-US"/>
+              <a:rPr lang="en-US" smtClean="0"/>
               <a:t>Click to edit Master subtitle style</a:t>
             </a:r>
+            <a:endParaRPr lang="en-US"/>
           </a:p>
         </p:txBody>
       </p:sp>
@@ -330,7 +309,7 @@
             <a:fld id="{1D8BD707-D9CF-40AE-B4C6-C98DA3205C09}" type="datetimeFigureOut">
               <a:rPr lang="en-US" smtClean="0"/>
               <a:pPr/>
-              <a:t>2/22/2026</a:t>
+              <a:t>8/1/2011</a:t>
             </a:fld>
             <a:endParaRPr lang="en-US"/>
           </a:p>
@@ -373,7 +352,7 @@
             <a:fld id="{B6F15528-21DE-4FAA-801E-634DDDAF4B2B}" type="slidenum">
               <a:rPr lang="en-US" smtClean="0"/>
               <a:pPr/>
-              <a:t>‹N°›</a:t>
+              <a:t>‹#›</a:t>
             </a:fld>
             <a:endParaRPr lang="en-US"/>
           </a:p>
@@ -420,9 +399,10 @@
           <a:lstStyle/>
           <a:p>
             <a:r>
-              <a:rPr lang="en-US"/>
+              <a:rPr lang="en-US" smtClean="0"/>
               <a:t>Click to edit Master title style</a:t>
             </a:r>
+            <a:endParaRPr lang="en-US"/>
           </a:p>
         </p:txBody>
       </p:sp>
@@ -443,37 +423,38 @@
           <a:p>
             <a:pPr lvl="0"/>
             <a:r>
-              <a:rPr lang="en-US"/>
+              <a:rPr lang="en-US" smtClean="0"/>
               <a:t>Click to edit Master text styles</a:t>
             </a:r>
           </a:p>
           <a:p>
             <a:pPr lvl="1"/>
             <a:r>
-              <a:rPr lang="en-US"/>
+              <a:rPr lang="en-US" smtClean="0"/>
               <a:t>Second level</a:t>
             </a:r>
           </a:p>
           <a:p>
             <a:pPr lvl="2"/>
             <a:r>
-              <a:rPr lang="en-US"/>
+              <a:rPr lang="en-US" smtClean="0"/>
               <a:t>Third level</a:t>
             </a:r>
           </a:p>
           <a:p>
             <a:pPr lvl="3"/>
             <a:r>
-              <a:rPr lang="en-US"/>
+              <a:rPr lang="en-US" smtClean="0"/>
               <a:t>Fourth level</a:t>
             </a:r>
           </a:p>
           <a:p>
             <a:pPr lvl="4"/>
             <a:r>
-              <a:rPr lang="en-US"/>
+              <a:rPr lang="en-US" smtClean="0"/>
               <a:t>Fifth level</a:t>
             </a:r>
+            <a:endParaRPr lang="en-US"/>
           </a:p>
         </p:txBody>
       </p:sp>
@@ -495,7 +476,7 @@
             <a:fld id="{1D8BD707-D9CF-40AE-B4C6-C98DA3205C09}" type="datetimeFigureOut">
               <a:rPr lang="en-US" smtClean="0"/>
               <a:pPr/>
-              <a:t>2/22/2026</a:t>
+              <a:t>8/1/2011</a:t>
             </a:fld>
             <a:endParaRPr lang="en-US"/>
           </a:p>
@@ -538,7 +519,7 @@
             <a:fld id="{B6F15528-21DE-4FAA-801E-634DDDAF4B2B}" type="slidenum">
               <a:rPr lang="en-US" smtClean="0"/>
               <a:pPr/>
-              <a:t>‹N°›</a:t>
+              <a:t>‹#›</a:t>
             </a:fld>
             <a:endParaRPr lang="en-US"/>
           </a:p>
@@ -590,9 +571,10 @@
           <a:lstStyle/>
           <a:p>
             <a:r>
-              <a:rPr lang="en-US"/>
+              <a:rPr lang="en-US" smtClean="0"/>
               <a:t>Click to edit Master title style</a:t>
             </a:r>
+            <a:endParaRPr lang="en-US"/>
           </a:p>
         </p:txBody>
       </p:sp>
@@ -618,37 +600,38 @@
           <a:p>
             <a:pPr lvl="0"/>
             <a:r>
-              <a:rPr lang="en-US"/>
+              <a:rPr lang="en-US" smtClean="0"/>
               <a:t>Click to edit Master text styles</a:t>
             </a:r>
           </a:p>
           <a:p>
             <a:pPr lvl="1"/>
             <a:r>
-              <a:rPr lang="en-US"/>
+              <a:rPr lang="en-US" smtClean="0"/>
               <a:t>Second level</a:t>
             </a:r>
           </a:p>
           <a:p>
             <a:pPr lvl="2"/>
             <a:r>
-              <a:rPr lang="en-US"/>
+              <a:rPr lang="en-US" smtClean="0"/>
               <a:t>Third level</a:t>
             </a:r>
           </a:p>
           <a:p>
             <a:pPr lvl="3"/>
             <a:r>
-              <a:rPr lang="en-US"/>
+              <a:rPr lang="en-US" smtClean="0"/>
               <a:t>Fourth level</a:t>
             </a:r>
           </a:p>
           <a:p>
             <a:pPr lvl="4"/>
             <a:r>
-              <a:rPr lang="en-US"/>
+              <a:rPr lang="en-US" smtClean="0"/>
               <a:t>Fifth level</a:t>
             </a:r>
+            <a:endParaRPr lang="en-US"/>
           </a:p>
         </p:txBody>
       </p:sp>
@@ -670,7 +653,7 @@
             <a:fld id="{1D8BD707-D9CF-40AE-B4C6-C98DA3205C09}" type="datetimeFigureOut">
               <a:rPr lang="en-US" smtClean="0"/>
               <a:pPr/>
-              <a:t>2/22/2026</a:t>
+              <a:t>8/1/2011</a:t>
             </a:fld>
             <a:endParaRPr lang="en-US"/>
           </a:p>
@@ -713,7 +696,7 @@
             <a:fld id="{B6F15528-21DE-4FAA-801E-634DDDAF4B2B}" type="slidenum">
               <a:rPr lang="en-US" smtClean="0"/>
               <a:pPr/>
-              <a:t>‹N°›</a:t>
+              <a:t>‹#›</a:t>
             </a:fld>
             <a:endParaRPr lang="en-US"/>
           </a:p>
@@ -760,9 +743,10 @@
           <a:lstStyle/>
           <a:p>
             <a:r>
-              <a:rPr lang="en-US"/>
+              <a:rPr lang="en-US" smtClean="0"/>
               <a:t>Click to edit Master title style</a:t>
             </a:r>
+            <a:endParaRPr lang="en-US"/>
           </a:p>
         </p:txBody>
       </p:sp>
@@ -783,37 +767,38 @@
           <a:p>
             <a:pPr lvl="0"/>
             <a:r>
-              <a:rPr lang="en-US"/>
+              <a:rPr lang="en-US" smtClean="0"/>
               <a:t>Click to edit Master text styles</a:t>
             </a:r>
           </a:p>
           <a:p>
             <a:pPr lvl="1"/>
             <a:r>
-              <a:rPr lang="en-US"/>
+              <a:rPr lang="en-US" smtClean="0"/>
               <a:t>Second level</a:t>
             </a:r>
           </a:p>
           <a:p>
             <a:pPr lvl="2"/>
             <a:r>
-              <a:rPr lang="en-US"/>
+              <a:rPr lang="en-US" smtClean="0"/>
               <a:t>Third level</a:t>
             </a:r>
           </a:p>
           <a:p>
             <a:pPr lvl="3"/>
             <a:r>
-              <a:rPr lang="en-US"/>
+              <a:rPr lang="en-US" smtClean="0"/>
               <a:t>Fourth level</a:t>
             </a:r>
           </a:p>
           <a:p>
             <a:pPr lvl="4"/>
             <a:r>
-              <a:rPr lang="en-US"/>
+              <a:rPr lang="en-US" smtClean="0"/>
               <a:t>Fifth level</a:t>
             </a:r>
+            <a:endParaRPr lang="en-US"/>
           </a:p>
         </p:txBody>
       </p:sp>
@@ -835,7 +820,7 @@
             <a:fld id="{1D8BD707-D9CF-40AE-B4C6-C98DA3205C09}" type="datetimeFigureOut">
               <a:rPr lang="en-US" smtClean="0"/>
               <a:pPr/>
-              <a:t>2/22/2026</a:t>
+              <a:t>8/1/2011</a:t>
             </a:fld>
             <a:endParaRPr lang="en-US"/>
           </a:p>
@@ -878,7 +863,7 @@
             <a:fld id="{B6F15528-21DE-4FAA-801E-634DDDAF4B2B}" type="slidenum">
               <a:rPr lang="en-US" smtClean="0"/>
               <a:pPr/>
-              <a:t>‹N°›</a:t>
+              <a:t>‹#›</a:t>
             </a:fld>
             <a:endParaRPr lang="en-US"/>
           </a:p>
@@ -934,9 +919,10 @@
           </a:lstStyle>
           <a:p>
             <a:r>
-              <a:rPr lang="en-US"/>
+              <a:rPr lang="en-US" smtClean="0"/>
               <a:t>Click to edit Master title style</a:t>
             </a:r>
+            <a:endParaRPr lang="en-US"/>
           </a:p>
         </p:txBody>
       </p:sp>
@@ -1053,7 +1039,7 @@
           <a:p>
             <a:pPr lvl="0"/>
             <a:r>
-              <a:rPr lang="en-US"/>
+              <a:rPr lang="en-US" smtClean="0"/>
               <a:t>Click to edit Master text styles</a:t>
             </a:r>
           </a:p>
@@ -1077,7 +1063,7 @@
             <a:fld id="{1D8BD707-D9CF-40AE-B4C6-C98DA3205C09}" type="datetimeFigureOut">
               <a:rPr lang="en-US" smtClean="0"/>
               <a:pPr/>
-              <a:t>2/22/2026</a:t>
+              <a:t>8/1/2011</a:t>
             </a:fld>
             <a:endParaRPr lang="en-US"/>
           </a:p>
@@ -1120,7 +1106,7 @@
             <a:fld id="{B6F15528-21DE-4FAA-801E-634DDDAF4B2B}" type="slidenum">
               <a:rPr lang="en-US" smtClean="0"/>
               <a:pPr/>
-              <a:t>‹N°›</a:t>
+              <a:t>‹#›</a:t>
             </a:fld>
             <a:endParaRPr lang="en-US"/>
           </a:p>
@@ -1167,9 +1153,10 @@
           <a:lstStyle/>
           <a:p>
             <a:r>
-              <a:rPr lang="en-US"/>
+              <a:rPr lang="en-US" smtClean="0"/>
               <a:t>Click to edit Master title style</a:t>
             </a:r>
+            <a:endParaRPr lang="en-US"/>
           </a:p>
         </p:txBody>
       </p:sp>
@@ -1223,37 +1210,38 @@
           <a:p>
             <a:pPr lvl="0"/>
             <a:r>
-              <a:rPr lang="en-US"/>
+              <a:rPr lang="en-US" smtClean="0"/>
               <a:t>Click to edit Master text styles</a:t>
             </a:r>
           </a:p>
           <a:p>
             <a:pPr lvl="1"/>
             <a:r>
-              <a:rPr lang="en-US"/>
+              <a:rPr lang="en-US" smtClean="0"/>
               <a:t>Second level</a:t>
             </a:r>
           </a:p>
           <a:p>
             <a:pPr lvl="2"/>
             <a:r>
-              <a:rPr lang="en-US"/>
+              <a:rPr lang="en-US" smtClean="0"/>
               <a:t>Third level</a:t>
             </a:r>
           </a:p>
           <a:p>
             <a:pPr lvl="3"/>
             <a:r>
-              <a:rPr lang="en-US"/>
+              <a:rPr lang="en-US" smtClean="0"/>
               <a:t>Fourth level</a:t>
             </a:r>
           </a:p>
           <a:p>
             <a:pPr lvl="4"/>
             <a:r>
-              <a:rPr lang="en-US"/>
+              <a:rPr lang="en-US" smtClean="0"/>
               <a:t>Fifth level</a:t>
             </a:r>
+            <a:endParaRPr lang="en-US"/>
           </a:p>
         </p:txBody>
       </p:sp>
@@ -1307,37 +1295,38 @@
           <a:p>
             <a:pPr lvl="0"/>
             <a:r>
-              <a:rPr lang="en-US"/>
+              <a:rPr lang="en-US" smtClean="0"/>
               <a:t>Click to edit Master text styles</a:t>
             </a:r>
           </a:p>
           <a:p>
             <a:pPr lvl="1"/>
             <a:r>
-              <a:rPr lang="en-US"/>
+              <a:rPr lang="en-US" smtClean="0"/>
               <a:t>Second level</a:t>
             </a:r>
           </a:p>
           <a:p>
             <a:pPr lvl="2"/>
             <a:r>
-              <a:rPr lang="en-US"/>
+              <a:rPr lang="en-US" smtClean="0"/>
               <a:t>Third level</a:t>
             </a:r>
           </a:p>
           <a:p>
             <a:pPr lvl="3"/>
             <a:r>
-              <a:rPr lang="en-US"/>
+              <a:rPr lang="en-US" smtClean="0"/>
               <a:t>Fourth level</a:t>
             </a:r>
           </a:p>
           <a:p>
             <a:pPr lvl="4"/>
             <a:r>
-              <a:rPr lang="en-US"/>
+              <a:rPr lang="en-US" smtClean="0"/>
               <a:t>Fifth level</a:t>
             </a:r>
+            <a:endParaRPr lang="en-US"/>
           </a:p>
         </p:txBody>
       </p:sp>
@@ -1359,7 +1348,7 @@
             <a:fld id="{1D8BD707-D9CF-40AE-B4C6-C98DA3205C09}" type="datetimeFigureOut">
               <a:rPr lang="en-US" smtClean="0"/>
               <a:pPr/>
-              <a:t>2/22/2026</a:t>
+              <a:t>8/1/2011</a:t>
             </a:fld>
             <a:endParaRPr lang="en-US"/>
           </a:p>
@@ -1402,7 +1391,7 @@
             <a:fld id="{B6F15528-21DE-4FAA-801E-634DDDAF4B2B}" type="slidenum">
               <a:rPr lang="en-US" smtClean="0"/>
               <a:pPr/>
-              <a:t>‹N°›</a:t>
+              <a:t>‹#›</a:t>
             </a:fld>
             <a:endParaRPr lang="en-US"/>
           </a:p>
@@ -1453,9 +1442,10 @@
           </a:lstStyle>
           <a:p>
             <a:r>
-              <a:rPr lang="en-US"/>
+              <a:rPr lang="en-US" smtClean="0"/>
               <a:t>Click to edit Master title style</a:t>
             </a:r>
+            <a:endParaRPr lang="en-US"/>
           </a:p>
         </p:txBody>
       </p:sp>
@@ -1518,7 +1508,7 @@
           <a:p>
             <a:pPr lvl="0"/>
             <a:r>
-              <a:rPr lang="en-US"/>
+              <a:rPr lang="en-US" smtClean="0"/>
               <a:t>Click to edit Master text styles</a:t>
             </a:r>
           </a:p>
@@ -1574,37 +1564,38 @@
           <a:p>
             <a:pPr lvl="0"/>
             <a:r>
-              <a:rPr lang="en-US"/>
+              <a:rPr lang="en-US" smtClean="0"/>
               <a:t>Click to edit Master text styles</a:t>
             </a:r>
           </a:p>
           <a:p>
             <a:pPr lvl="1"/>
             <a:r>
-              <a:rPr lang="en-US"/>
+              <a:rPr lang="en-US" smtClean="0"/>
               <a:t>Second level</a:t>
             </a:r>
           </a:p>
           <a:p>
             <a:pPr lvl="2"/>
             <a:r>
-              <a:rPr lang="en-US"/>
+              <a:rPr lang="en-US" smtClean="0"/>
               <a:t>Third level</a:t>
             </a:r>
           </a:p>
           <a:p>
             <a:pPr lvl="3"/>
             <a:r>
-              <a:rPr lang="en-US"/>
+              <a:rPr lang="en-US" smtClean="0"/>
               <a:t>Fourth level</a:t>
             </a:r>
           </a:p>
           <a:p>
             <a:pPr lvl="4"/>
             <a:r>
-              <a:rPr lang="en-US"/>
+              <a:rPr lang="en-US" smtClean="0"/>
               <a:t>Fifth level</a:t>
             </a:r>
+            <a:endParaRPr lang="en-US"/>
           </a:p>
         </p:txBody>
       </p:sp>
@@ -1667,7 +1658,7 @@
           <a:p>
             <a:pPr lvl="0"/>
             <a:r>
-              <a:rPr lang="en-US"/>
+              <a:rPr lang="en-US" smtClean="0"/>
               <a:t>Click to edit Master text styles</a:t>
             </a:r>
           </a:p>
@@ -1723,37 +1714,38 @@
           <a:p>
             <a:pPr lvl="0"/>
             <a:r>
-              <a:rPr lang="en-US"/>
+              <a:rPr lang="en-US" smtClean="0"/>
               <a:t>Click to edit Master text styles</a:t>
             </a:r>
           </a:p>
           <a:p>
             <a:pPr lvl="1"/>
             <a:r>
-              <a:rPr lang="en-US"/>
+              <a:rPr lang="en-US" smtClean="0"/>
               <a:t>Second level</a:t>
             </a:r>
           </a:p>
           <a:p>
             <a:pPr lvl="2"/>
             <a:r>
-              <a:rPr lang="en-US"/>
+              <a:rPr lang="en-US" smtClean="0"/>
               <a:t>Third level</a:t>
             </a:r>
           </a:p>
           <a:p>
             <a:pPr lvl="3"/>
             <a:r>
-              <a:rPr lang="en-US"/>
+              <a:rPr lang="en-US" smtClean="0"/>
               <a:t>Fourth level</a:t>
             </a:r>
           </a:p>
           <a:p>
             <a:pPr lvl="4"/>
             <a:r>
-              <a:rPr lang="en-US"/>
+              <a:rPr lang="en-US" smtClean="0"/>
               <a:t>Fifth level</a:t>
             </a:r>
+            <a:endParaRPr lang="en-US"/>
           </a:p>
         </p:txBody>
       </p:sp>
@@ -1775,7 +1767,7 @@
             <a:fld id="{1D8BD707-D9CF-40AE-B4C6-C98DA3205C09}" type="datetimeFigureOut">
               <a:rPr lang="en-US" smtClean="0"/>
               <a:pPr/>
-              <a:t>2/22/2026</a:t>
+              <a:t>8/1/2011</a:t>
             </a:fld>
             <a:endParaRPr lang="en-US"/>
           </a:p>
@@ -1818,7 +1810,7 @@
             <a:fld id="{B6F15528-21DE-4FAA-801E-634DDDAF4B2B}" type="slidenum">
               <a:rPr lang="en-US" smtClean="0"/>
               <a:pPr/>
-              <a:t>‹N°›</a:t>
+              <a:t>‹#›</a:t>
             </a:fld>
             <a:endParaRPr lang="en-US"/>
           </a:p>
@@ -1865,9 +1857,10 @@
           <a:lstStyle/>
           <a:p>
             <a:r>
-              <a:rPr lang="en-US"/>
+              <a:rPr lang="en-US" smtClean="0"/>
               <a:t>Click to edit Master title style</a:t>
             </a:r>
+            <a:endParaRPr lang="en-US"/>
           </a:p>
         </p:txBody>
       </p:sp>
@@ -1889,7 +1882,7 @@
             <a:fld id="{1D8BD707-D9CF-40AE-B4C6-C98DA3205C09}" type="datetimeFigureOut">
               <a:rPr lang="en-US" smtClean="0"/>
               <a:pPr/>
-              <a:t>2/22/2026</a:t>
+              <a:t>8/1/2011</a:t>
             </a:fld>
             <a:endParaRPr lang="en-US"/>
           </a:p>
@@ -1932,7 +1925,7 @@
             <a:fld id="{B6F15528-21DE-4FAA-801E-634DDDAF4B2B}" type="slidenum">
               <a:rPr lang="en-US" smtClean="0"/>
               <a:pPr/>
-              <a:t>‹N°›</a:t>
+              <a:t>‹#›</a:t>
             </a:fld>
             <a:endParaRPr lang="en-US"/>
           </a:p>
@@ -1981,7 +1974,7 @@
             <a:fld id="{1D8BD707-D9CF-40AE-B4C6-C98DA3205C09}" type="datetimeFigureOut">
               <a:rPr lang="en-US" smtClean="0"/>
               <a:pPr/>
-              <a:t>2/22/2026</a:t>
+              <a:t>8/1/2011</a:t>
             </a:fld>
             <a:endParaRPr lang="en-US"/>
           </a:p>
@@ -2024,7 +2017,7 @@
             <a:fld id="{B6F15528-21DE-4FAA-801E-634DDDAF4B2B}" type="slidenum">
               <a:rPr lang="en-US" smtClean="0"/>
               <a:pPr/>
-              <a:t>‹N°›</a:t>
+              <a:t>‹#›</a:t>
             </a:fld>
             <a:endParaRPr lang="en-US"/>
           </a:p>
@@ -2080,9 +2073,10 @@
           </a:lstStyle>
           <a:p>
             <a:r>
-              <a:rPr lang="en-US"/>
+              <a:rPr lang="en-US" smtClean="0"/>
               <a:t>Click to edit Master title style</a:t>
             </a:r>
+            <a:endParaRPr lang="en-US"/>
           </a:p>
         </p:txBody>
       </p:sp>
@@ -2136,37 +2130,38 @@
           <a:p>
             <a:pPr lvl="0"/>
             <a:r>
-              <a:rPr lang="en-US"/>
+              <a:rPr lang="en-US" smtClean="0"/>
               <a:t>Click to edit Master text styles</a:t>
             </a:r>
           </a:p>
           <a:p>
             <a:pPr lvl="1"/>
             <a:r>
-              <a:rPr lang="en-US"/>
+              <a:rPr lang="en-US" smtClean="0"/>
               <a:t>Second level</a:t>
             </a:r>
           </a:p>
           <a:p>
             <a:pPr lvl="2"/>
             <a:r>
-              <a:rPr lang="en-US"/>
+              <a:rPr lang="en-US" smtClean="0"/>
               <a:t>Third level</a:t>
             </a:r>
           </a:p>
           <a:p>
             <a:pPr lvl="3"/>
             <a:r>
-              <a:rPr lang="en-US"/>
+              <a:rPr lang="en-US" smtClean="0"/>
               <a:t>Fourth level</a:t>
             </a:r>
           </a:p>
           <a:p>
             <a:pPr lvl="4"/>
             <a:r>
-              <a:rPr lang="en-US"/>
+              <a:rPr lang="en-US" smtClean="0"/>
               <a:t>Fifth level</a:t>
             </a:r>
+            <a:endParaRPr lang="en-US"/>
           </a:p>
         </p:txBody>
       </p:sp>
@@ -2229,7 +2224,7 @@
           <a:p>
             <a:pPr lvl="0"/>
             <a:r>
-              <a:rPr lang="en-US"/>
+              <a:rPr lang="en-US" smtClean="0"/>
               <a:t>Click to edit Master text styles</a:t>
             </a:r>
           </a:p>
@@ -2253,7 +2248,7 @@
             <a:fld id="{1D8BD707-D9CF-40AE-B4C6-C98DA3205C09}" type="datetimeFigureOut">
               <a:rPr lang="en-US" smtClean="0"/>
               <a:pPr/>
-              <a:t>2/22/2026</a:t>
+              <a:t>8/1/2011</a:t>
             </a:fld>
             <a:endParaRPr lang="en-US"/>
           </a:p>
@@ -2296,7 +2291,7 @@
             <a:fld id="{B6F15528-21DE-4FAA-801E-634DDDAF4B2B}" type="slidenum">
               <a:rPr lang="en-US" smtClean="0"/>
               <a:pPr/>
-              <a:t>‹N°›</a:t>
+              <a:t>‹#›</a:t>
             </a:fld>
             <a:endParaRPr lang="en-US"/>
           </a:p>
@@ -2352,9 +2347,10 @@
           </a:lstStyle>
           <a:p>
             <a:r>
-              <a:rPr lang="en-US"/>
+              <a:rPr lang="en-US" smtClean="0"/>
               <a:t>Click to edit Master title style</a:t>
             </a:r>
+            <a:endParaRPr lang="en-US"/>
           </a:p>
         </p:txBody>
       </p:sp>
@@ -2478,7 +2474,7 @@
           <a:p>
             <a:pPr lvl="0"/>
             <a:r>
-              <a:rPr lang="en-US"/>
+              <a:rPr lang="en-US" smtClean="0"/>
               <a:t>Click to edit Master text styles</a:t>
             </a:r>
           </a:p>
@@ -2502,7 +2498,7 @@
             <a:fld id="{1D8BD707-D9CF-40AE-B4C6-C98DA3205C09}" type="datetimeFigureOut">
               <a:rPr lang="en-US" smtClean="0"/>
               <a:pPr/>
-              <a:t>2/22/2026</a:t>
+              <a:t>8/1/2011</a:t>
             </a:fld>
             <a:endParaRPr lang="en-US"/>
           </a:p>
@@ -2545,7 +2541,7 @@
             <a:fld id="{B6F15528-21DE-4FAA-801E-634DDDAF4B2B}" type="slidenum">
               <a:rPr lang="en-US" smtClean="0"/>
               <a:pPr/>
-              <a:t>‹N°›</a:t>
+              <a:t>‹#›</a:t>
             </a:fld>
             <a:endParaRPr lang="en-US"/>
           </a:p>
@@ -2607,9 +2603,10 @@
           <a:lstStyle/>
           <a:p>
             <a:r>
-              <a:rPr lang="en-US"/>
+              <a:rPr lang="en-US" smtClean="0"/>
               <a:t>Click to edit Master title style</a:t>
             </a:r>
+            <a:endParaRPr lang="en-US"/>
           </a:p>
         </p:txBody>
       </p:sp>
@@ -2640,37 +2637,38 @@
           <a:p>
             <a:pPr lvl="0"/>
             <a:r>
-              <a:rPr lang="en-US"/>
+              <a:rPr lang="en-US" smtClean="0"/>
               <a:t>Click to edit Master text styles</a:t>
             </a:r>
           </a:p>
           <a:p>
             <a:pPr lvl="1"/>
             <a:r>
-              <a:rPr lang="en-US"/>
+              <a:rPr lang="en-US" smtClean="0"/>
               <a:t>Second level</a:t>
             </a:r>
           </a:p>
           <a:p>
             <a:pPr lvl="2"/>
             <a:r>
-              <a:rPr lang="en-US"/>
+              <a:rPr lang="en-US" smtClean="0"/>
               <a:t>Third level</a:t>
             </a:r>
           </a:p>
           <a:p>
             <a:pPr lvl="3"/>
             <a:r>
-              <a:rPr lang="en-US"/>
+              <a:rPr lang="en-US" smtClean="0"/>
               <a:t>Fourth level</a:t>
             </a:r>
           </a:p>
           <a:p>
             <a:pPr lvl="4"/>
             <a:r>
-              <a:rPr lang="en-US"/>
+              <a:rPr lang="en-US" smtClean="0"/>
               <a:t>Fifth level</a:t>
             </a:r>
+            <a:endParaRPr lang="en-US"/>
           </a:p>
         </p:txBody>
       </p:sp>
@@ -2710,7 +2708,7 @@
             <a:fld id="{1D8BD707-D9CF-40AE-B4C6-C98DA3205C09}" type="datetimeFigureOut">
               <a:rPr lang="en-US" smtClean="0"/>
               <a:pPr/>
-              <a:t>2/22/2026</a:t>
+              <a:t>8/1/2011</a:t>
             </a:fld>
             <a:endParaRPr lang="en-US"/>
           </a:p>
@@ -2789,7 +2787,7 @@
             <a:fld id="{B6F15528-21DE-4FAA-801E-634DDDAF4B2B}" type="slidenum">
               <a:rPr lang="en-US" smtClean="0"/>
               <a:pPr/>
-              <a:t>‹N°›</a:t>
+              <a:t>‹#›</a:t>
             </a:fld>
             <a:endParaRPr lang="en-US"/>
           </a:p>
@@ -3065,14 +3063,13 @@
 </file>
 
 <file path=ppt/slides/slide1.xml><?xml version="1.0" encoding="utf-8"?>
-<p:sld xmlns:a="http://schemas.openxmlformats.org/drawingml/2006/main" xmlns:r="http://schemas.openxmlformats.org/officeDocument/2006/relationships" xmlns:p="http://schemas.openxmlformats.org/presentationml/2006/main">
+<p:sld xmlns:p="http://schemas.openxmlformats.org/presentationml/2006/main" xmlns:a="http://schemas.openxmlformats.org/drawingml/2006/main" xmlns:r="http://schemas.openxmlformats.org/officeDocument/2006/relationships">
   <p:cSld>
     <p:bg>
       <p:bgPr>
         <a:solidFill>
           <a:srgbClr val="EAF0FF"/>
         </a:solidFill>
-        <a:effectLst/>
       </p:bgPr>
     </p:bg>
     <p:spTree>
@@ -3091,12 +3088,12 @@
       </p:grpSpPr>
       <p:sp>
         <p:nvSpPr>
-          <p:cNvPr id="2" name="Freeform 2"/>
+          <p:cNvPr name="Freeform 2" id="2"/>
           <p:cNvSpPr/>
           <p:nvPr/>
         </p:nvSpPr>
         <p:spPr>
-          <a:xfrm>
+          <a:xfrm flipH="false" flipV="false" rot="0">
             <a:off x="14368061" y="7310520"/>
             <a:ext cx="3255989" cy="2504607"/>
           </a:xfrm>
@@ -3105,9 +3102,9 @@
             <a:gdLst/>
             <a:ahLst/>
             <a:cxnLst/>
-            <a:rect l="l" t="t" r="r" b="b"/>
+            <a:rect r="r" b="b" t="t" l="l"/>
             <a:pathLst>
-              <a:path w="3255989" h="2504607">
+              <a:path h="2504607" w="3255989">
                 <a:moveTo>
                   <a:pt x="0" y="0"/>
                 </a:moveTo>
@@ -3130,19 +3127,19 @@
           <a:blipFill>
             <a:blip r:embed="rId2"/>
             <a:stretch>
-              <a:fillRect/>
+              <a:fillRect l="0" t="0" r="0" b="0"/>
             </a:stretch>
           </a:blipFill>
         </p:spPr>
       </p:sp>
       <p:sp>
         <p:nvSpPr>
-          <p:cNvPr id="3" name="TextBox 3"/>
-          <p:cNvSpPr txBox="1"/>
+          <p:cNvPr name="TextBox 3" id="3"/>
+          <p:cNvSpPr txBox="true"/>
           <p:nvPr/>
         </p:nvSpPr>
         <p:spPr>
-          <a:xfrm>
+          <a:xfrm rot="0">
             <a:off x="1028700" y="1121148"/>
             <a:ext cx="16230600" cy="1510745"/>
           </a:xfrm>
@@ -3151,12 +3148,12 @@
           </a:prstGeom>
         </p:spPr>
         <p:txBody>
-          <a:bodyPr lIns="0" tIns="0" rIns="0" bIns="0" rtlCol="0" anchor="t">
+          <a:bodyPr anchor="t" rtlCol="false" tIns="0" lIns="0" bIns="0" rIns="0">
             <a:spAutoFit/>
           </a:bodyPr>
           <a:lstStyle/>
           <a:p>
-            <a:pPr marL="0" lvl="0" indent="0" algn="ctr">
+            <a:pPr algn="ctr" marL="0" indent="0" lvl="0">
               <a:lnSpc>
                 <a:spcPts val="11755"/>
               </a:lnSpc>
@@ -3177,7 +3174,7 @@
               <a:t>Intr</a:t>
             </a:r>
             <a:r>
-              <a:rPr lang="en-US" sz="8396" u="none" strike="noStrike" spc="419">
+              <a:rPr lang="en-US" sz="8396" spc="419" strike="noStrike" u="none">
                 <a:solidFill>
                   <a:srgbClr val="56678D"/>
                 </a:solidFill>
@@ -3186,19 +3183,55 @@
                 <a:cs typeface="Boston Angel"/>
                 <a:sym typeface="Boston Angel"/>
               </a:rPr>
-              <a:t>oduction</a:t>
-            </a:r>
-          </a:p>
-        </p:txBody>
-      </p:sp>
-      <p:sp>
-        <p:nvSpPr>
-          <p:cNvPr id="4" name="TextBox 4"/>
-          <p:cNvSpPr txBox="1"/>
+              <a:t>o</a:t>
+            </a:r>
+            <a:r>
+              <a:rPr lang="en-US" sz="8396" spc="419" strike="noStrike" u="none">
+                <a:solidFill>
+                  <a:srgbClr val="56678D"/>
+                </a:solidFill>
+                <a:latin typeface="Boston Angel"/>
+                <a:ea typeface="Boston Angel"/>
+                <a:cs typeface="Boston Angel"/>
+                <a:sym typeface="Boston Angel"/>
+              </a:rPr>
+              <a:t>duct</a:t>
+            </a:r>
+            <a:r>
+              <a:rPr lang="en-US" sz="8396" spc="419" strike="noStrike" u="none">
+                <a:solidFill>
+                  <a:srgbClr val="56678D"/>
+                </a:solidFill>
+                <a:latin typeface="Boston Angel"/>
+                <a:ea typeface="Boston Angel"/>
+                <a:cs typeface="Boston Angel"/>
+                <a:sym typeface="Boston Angel"/>
+              </a:rPr>
+              <a:t>i</a:t>
+            </a:r>
+            <a:r>
+              <a:rPr lang="en-US" sz="8396" spc="419" strike="noStrike" u="none">
+                <a:solidFill>
+                  <a:srgbClr val="56678D"/>
+                </a:solidFill>
+                <a:latin typeface="Boston Angel"/>
+                <a:ea typeface="Boston Angel"/>
+                <a:cs typeface="Boston Angel"/>
+                <a:sym typeface="Boston Angel"/>
+              </a:rPr>
+              <a:t>on</a:t>
+            </a:r>
+          </a:p>
+        </p:txBody>
+      </p:sp>
+      <p:sp>
+        <p:nvSpPr>
+          <p:cNvPr name="TextBox 4" id="4"/>
+          <p:cNvSpPr txBox="true"/>
           <p:nvPr/>
         </p:nvSpPr>
         <p:spPr>
-          <a:xfrm>
+          <a:xfrm rot="0">
             <a:off x="903525" y="3377121"/>
             <a:ext cx="16078388" cy="1583839"/>
           </a:xfrm>
@@ -3207,12 +3240,12 @@
           </a:prstGeom>
         </p:spPr>
         <p:txBody>
-          <a:bodyPr lIns="0" tIns="0" rIns="0" bIns="0" rtlCol="0" anchor="t">
+          <a:bodyPr anchor="t" rtlCol="false" tIns="0" lIns="0" bIns="0" rIns="0">
             <a:spAutoFit/>
           </a:bodyPr>
           <a:lstStyle/>
           <a:p>
-            <a:pPr marL="949961" lvl="1" indent="-474980" algn="l">
+            <a:pPr algn="l" marL="949961" indent="-474980" lvl="1">
               <a:lnSpc>
                 <a:spcPts val="6160"/>
               </a:lnSpc>
@@ -3239,12 +3272,12 @@
       </p:sp>
       <p:sp>
         <p:nvSpPr>
-          <p:cNvPr id="5" name="TextBox 5"/>
-          <p:cNvSpPr txBox="1"/>
+          <p:cNvPr name="TextBox 5" id="5"/>
+          <p:cNvSpPr txBox="true"/>
           <p:nvPr/>
         </p:nvSpPr>
         <p:spPr>
-          <a:xfrm>
+          <a:xfrm rot="0">
             <a:off x="762349" y="5864002"/>
             <a:ext cx="16219564" cy="2364963"/>
           </a:xfrm>
@@ -3253,12 +3286,12 @@
           </a:prstGeom>
         </p:spPr>
         <p:txBody>
-          <a:bodyPr lIns="0" tIns="0" rIns="0" bIns="0" rtlCol="0" anchor="t">
+          <a:bodyPr anchor="t" rtlCol="false" tIns="0" lIns="0" bIns="0" rIns="0">
             <a:spAutoFit/>
           </a:bodyPr>
           <a:lstStyle/>
           <a:p>
-            <a:pPr marL="949961" lvl="1" indent="-474980" algn="l">
+            <a:pPr algn="l" marL="949961" indent="-474980" lvl="1">
               <a:lnSpc>
                 <a:spcPts val="6160"/>
               </a:lnSpc>
@@ -3290,15 +3323,6 @@
                 <a:spcPct val="0"/>
               </a:spcBef>
             </a:pPr>
-            <a:endParaRPr lang="en-US" sz="4400" spc="220">
-              <a:solidFill>
-                <a:srgbClr val="56678D"/>
-              </a:solidFill>
-              <a:latin typeface="Boston Angel"/>
-              <a:ea typeface="Boston Angel"/>
-              <a:cs typeface="Boston Angel"/>
-              <a:sym typeface="Boston Angel"/>
-            </a:endParaRPr>
           </a:p>
         </p:txBody>
       </p:sp>
@@ -3311,14 +3335,13 @@
 </file>
 
 <file path=ppt/slides/slide2.xml><?xml version="1.0" encoding="utf-8"?>
-<p:sld xmlns:a="http://schemas.openxmlformats.org/drawingml/2006/main" xmlns:r="http://schemas.openxmlformats.org/officeDocument/2006/relationships" xmlns:p="http://schemas.openxmlformats.org/presentationml/2006/main">
+<p:sld xmlns:p="http://schemas.openxmlformats.org/presentationml/2006/main" xmlns:a="http://schemas.openxmlformats.org/drawingml/2006/main" xmlns:r="http://schemas.openxmlformats.org/officeDocument/2006/relationships">
   <p:cSld>
     <p:bg>
       <p:bgPr>
         <a:solidFill>
           <a:srgbClr val="EAF0FF"/>
         </a:solidFill>
-        <a:effectLst/>
       </p:bgPr>
     </p:bg>
     <p:spTree>
@@ -3337,23 +3360,23 @@
       </p:grpSpPr>
       <p:sp>
         <p:nvSpPr>
-          <p:cNvPr id="2" name="Freeform 2"/>
+          <p:cNvPr name="Freeform 2" id="2"/>
           <p:cNvSpPr/>
           <p:nvPr/>
         </p:nvSpPr>
         <p:spPr>
-          <a:xfrm>
-            <a:off x="6324600" y="2631893"/>
-            <a:ext cx="10406686" cy="6846684"/>
+          <a:xfrm flipH="false" flipV="false" rot="0">
+            <a:off x="7559646" y="3723373"/>
+            <a:ext cx="9171640" cy="5755204"/>
           </a:xfrm>
           <a:custGeom>
             <a:avLst/>
             <a:gdLst/>
             <a:ahLst/>
             <a:cxnLst/>
-            <a:rect l="l" t="t" r="r" b="b"/>
+            <a:rect r="r" b="b" t="t" l="l"/>
             <a:pathLst>
-              <a:path w="9171640" h="5755204">
+              <a:path h="5755204" w="9171640">
                 <a:moveTo>
                   <a:pt x="0" y="0"/>
                 </a:moveTo>
@@ -3376,19 +3399,19 @@
           <a:blipFill>
             <a:blip r:embed="rId2"/>
             <a:stretch>
-              <a:fillRect/>
+              <a:fillRect l="0" t="0" r="0" b="0"/>
             </a:stretch>
           </a:blipFill>
         </p:spPr>
       </p:sp>
       <p:sp>
         <p:nvSpPr>
-          <p:cNvPr id="3" name="TextBox 3"/>
-          <p:cNvSpPr txBox="1"/>
+          <p:cNvPr name="TextBox 3" id="3"/>
+          <p:cNvSpPr txBox="true"/>
           <p:nvPr/>
         </p:nvSpPr>
         <p:spPr>
-          <a:xfrm>
+          <a:xfrm rot="0">
             <a:off x="338822" y="3420264"/>
             <a:ext cx="6424345" cy="2469131"/>
           </a:xfrm>
@@ -3397,7 +3420,7 @@
           </a:prstGeom>
         </p:spPr>
         <p:txBody>
-          <a:bodyPr lIns="0" tIns="0" rIns="0" bIns="0" rtlCol="0" anchor="t">
+          <a:bodyPr anchor="t" rtlCol="false" tIns="0" lIns="0" bIns="0" rIns="0">
             <a:spAutoFit/>
           </a:bodyPr>
           <a:lstStyle/>
@@ -3424,12 +3447,12 @@
       </p:sp>
       <p:sp>
         <p:nvSpPr>
-          <p:cNvPr id="4" name="TextBox 4"/>
-          <p:cNvSpPr txBox="1"/>
+          <p:cNvPr name="TextBox 4" id="4"/>
+          <p:cNvSpPr txBox="true"/>
           <p:nvPr/>
         </p:nvSpPr>
         <p:spPr>
-          <a:xfrm>
+          <a:xfrm rot="0">
             <a:off x="1028700" y="1121148"/>
             <a:ext cx="16230600" cy="1510745"/>
           </a:xfrm>
@@ -3438,12 +3461,12 @@
           </a:prstGeom>
         </p:spPr>
         <p:txBody>
-          <a:bodyPr lIns="0" tIns="0" rIns="0" bIns="0" rtlCol="0" anchor="t">
+          <a:bodyPr anchor="t" rtlCol="false" tIns="0" lIns="0" bIns="0" rIns="0">
             <a:spAutoFit/>
           </a:bodyPr>
           <a:lstStyle/>
           <a:p>
-            <a:pPr marL="0" lvl="0" indent="0" algn="ctr">
+            <a:pPr algn="ctr" marL="0" indent="0" lvl="0">
               <a:lnSpc>
                 <a:spcPts val="11755"/>
               </a:lnSpc>
@@ -3475,14 +3498,13 @@
 </file>
 
 <file path=ppt/slides/slide3.xml><?xml version="1.0" encoding="utf-8"?>
-<p:sld xmlns:a="http://schemas.openxmlformats.org/drawingml/2006/main" xmlns:r="http://schemas.openxmlformats.org/officeDocument/2006/relationships" xmlns:p="http://schemas.openxmlformats.org/presentationml/2006/main">
+<p:sld xmlns:p="http://schemas.openxmlformats.org/presentationml/2006/main" xmlns:a="http://schemas.openxmlformats.org/drawingml/2006/main" xmlns:r="http://schemas.openxmlformats.org/officeDocument/2006/relationships">
   <p:cSld>
     <p:bg>
       <p:bgPr>
         <a:solidFill>
           <a:srgbClr val="EAF0FF"/>
         </a:solidFill>
-        <a:effectLst/>
       </p:bgPr>
     </p:bg>
     <p:spTree>
@@ -3501,23 +3523,23 @@
       </p:grpSpPr>
       <p:sp>
         <p:nvSpPr>
-          <p:cNvPr id="2" name="Freeform 2"/>
+          <p:cNvPr name="Freeform 2" id="2"/>
           <p:cNvSpPr/>
           <p:nvPr/>
         </p:nvSpPr>
         <p:spPr>
-          <a:xfrm>
-            <a:off x="3501285" y="2781301"/>
-            <a:ext cx="14024715" cy="6900448"/>
+          <a:xfrm flipH="false" flipV="false" rot="0">
+            <a:off x="3501285" y="3556647"/>
+            <a:ext cx="13687377" cy="6125101"/>
           </a:xfrm>
           <a:custGeom>
             <a:avLst/>
             <a:gdLst/>
             <a:ahLst/>
             <a:cxnLst/>
-            <a:rect l="l" t="t" r="r" b="b"/>
+            <a:rect r="r" b="b" t="t" l="l"/>
             <a:pathLst>
-              <a:path w="13687377" h="6125101">
+              <a:path h="6125101" w="13687377">
                 <a:moveTo>
                   <a:pt x="0" y="0"/>
                 </a:moveTo>
@@ -3540,19 +3562,19 @@
           <a:blipFill>
             <a:blip r:embed="rId2"/>
             <a:stretch>
-              <a:fillRect/>
+              <a:fillRect l="0" t="0" r="0" b="0"/>
             </a:stretch>
           </a:blipFill>
         </p:spPr>
       </p:sp>
       <p:sp>
         <p:nvSpPr>
-          <p:cNvPr id="3" name="TextBox 3"/>
-          <p:cNvSpPr txBox="1"/>
+          <p:cNvPr name="TextBox 3" id="3"/>
+          <p:cNvSpPr txBox="true"/>
           <p:nvPr/>
         </p:nvSpPr>
         <p:spPr>
-          <a:xfrm>
+          <a:xfrm rot="0">
             <a:off x="376469" y="3420264"/>
             <a:ext cx="3431418" cy="3092246"/>
           </a:xfrm>
@@ -3561,7 +3583,7 @@
           </a:prstGeom>
         </p:spPr>
         <p:txBody>
-          <a:bodyPr lIns="0" tIns="0" rIns="0" bIns="0" rtlCol="0" anchor="t">
+          <a:bodyPr anchor="t" rtlCol="false" tIns="0" lIns="0" bIns="0" rIns="0">
             <a:spAutoFit/>
           </a:bodyPr>
           <a:lstStyle/>
@@ -3588,12 +3610,12 @@
       </p:sp>
       <p:sp>
         <p:nvSpPr>
-          <p:cNvPr id="4" name="TextBox 4"/>
-          <p:cNvSpPr txBox="1"/>
+          <p:cNvPr name="TextBox 4" id="4"/>
+          <p:cNvSpPr txBox="true"/>
           <p:nvPr/>
         </p:nvSpPr>
         <p:spPr>
-          <a:xfrm>
+          <a:xfrm rot="0">
             <a:off x="1028700" y="1121148"/>
             <a:ext cx="16230600" cy="1510745"/>
           </a:xfrm>
@@ -3602,12 +3624,12 @@
           </a:prstGeom>
         </p:spPr>
         <p:txBody>
-          <a:bodyPr lIns="0" tIns="0" rIns="0" bIns="0" rtlCol="0" anchor="t">
+          <a:bodyPr anchor="t" rtlCol="false" tIns="0" lIns="0" bIns="0" rIns="0">
             <a:spAutoFit/>
           </a:bodyPr>
           <a:lstStyle/>
           <a:p>
-            <a:pPr marL="0" lvl="0" indent="0" algn="ctr">
+            <a:pPr algn="ctr" marL="0" indent="0" lvl="0">
               <a:lnSpc>
                 <a:spcPts val="11755"/>
               </a:lnSpc>
@@ -3639,14 +3661,13 @@
 </file>
 
 <file path=ppt/slides/slide4.xml><?xml version="1.0" encoding="utf-8"?>
-<p:sld xmlns:a="http://schemas.openxmlformats.org/drawingml/2006/main" xmlns:r="http://schemas.openxmlformats.org/officeDocument/2006/relationships" xmlns:p="http://schemas.openxmlformats.org/presentationml/2006/main">
+<p:sld xmlns:p="http://schemas.openxmlformats.org/presentationml/2006/main" xmlns:a="http://schemas.openxmlformats.org/drawingml/2006/main" xmlns:r="http://schemas.openxmlformats.org/officeDocument/2006/relationships">
   <p:cSld>
     <p:bg>
       <p:bgPr>
         <a:solidFill>
           <a:srgbClr val="EAF0FF"/>
         </a:solidFill>
-        <a:effectLst/>
       </p:bgPr>
     </p:bg>
     <p:spTree>
@@ -3665,23 +3686,23 @@
       </p:grpSpPr>
       <p:sp>
         <p:nvSpPr>
-          <p:cNvPr id="2" name="Freeform 2"/>
+          <p:cNvPr name="Freeform 2" id="2"/>
           <p:cNvSpPr/>
           <p:nvPr/>
         </p:nvSpPr>
         <p:spPr>
-          <a:xfrm>
-            <a:off x="9906000" y="2857500"/>
-            <a:ext cx="7156365" cy="6761956"/>
+          <a:xfrm flipH="false" flipV="false" rot="0">
+            <a:off x="10008515" y="2631893"/>
+            <a:ext cx="5022765" cy="5999956"/>
           </a:xfrm>
           <a:custGeom>
             <a:avLst/>
             <a:gdLst/>
             <a:ahLst/>
             <a:cxnLst/>
-            <a:rect l="l" t="t" r="r" b="b"/>
+            <a:rect r="r" b="b" t="t" l="l"/>
             <a:pathLst>
-              <a:path w="5022765" h="5999956">
+              <a:path h="5999956" w="5022765">
                 <a:moveTo>
                   <a:pt x="0" y="0"/>
                 </a:moveTo>
@@ -3704,19 +3725,19 @@
           <a:blipFill>
             <a:blip r:embed="rId2"/>
             <a:stretch>
-              <a:fillRect/>
+              <a:fillRect l="0" t="0" r="0" b="0"/>
             </a:stretch>
           </a:blipFill>
         </p:spPr>
       </p:sp>
       <p:sp>
         <p:nvSpPr>
-          <p:cNvPr id="3" name="TextBox 3"/>
-          <p:cNvSpPr txBox="1"/>
+          <p:cNvPr name="TextBox 3" id="3"/>
+          <p:cNvSpPr txBox="true"/>
           <p:nvPr/>
         </p:nvSpPr>
         <p:spPr>
-          <a:xfrm>
+          <a:xfrm rot="0">
             <a:off x="269591" y="3268562"/>
             <a:ext cx="9202412" cy="4059710"/>
           </a:xfrm>
@@ -3725,12 +3746,12 @@
           </a:prstGeom>
         </p:spPr>
         <p:txBody>
-          <a:bodyPr lIns="0" tIns="0" rIns="0" bIns="0" rtlCol="0" anchor="t">
+          <a:bodyPr anchor="t" rtlCol="false" tIns="0" lIns="0" bIns="0" rIns="0">
             <a:spAutoFit/>
           </a:bodyPr>
           <a:lstStyle/>
           <a:p>
-            <a:pPr marL="835253" lvl="1" indent="-417627" algn="l">
+            <a:pPr algn="l" marL="835253" indent="-417627" lvl="1">
               <a:lnSpc>
                 <a:spcPts val="5416"/>
               </a:lnSpc>
@@ -3756,18 +3777,9 @@
                 <a:spcPts val="5416"/>
               </a:lnSpc>
             </a:pPr>
-            <a:endParaRPr lang="en-US" sz="3868" spc="116">
-              <a:solidFill>
-                <a:srgbClr val="56678D"/>
-              </a:solidFill>
-              <a:latin typeface="29LT Riwaya"/>
-              <a:ea typeface="29LT Riwaya"/>
-              <a:cs typeface="29LT Riwaya"/>
-              <a:sym typeface="29LT Riwaya"/>
-            </a:endParaRPr>
-          </a:p>
-          <a:p>
-            <a:pPr marL="835253" lvl="1" indent="-417627" algn="l">
+          </a:p>
+          <a:p>
+            <a:pPr algn="l" marL="835253" indent="-417627" lvl="1">
               <a:lnSpc>
                 <a:spcPts val="5416"/>
               </a:lnSpc>
@@ -3793,26 +3805,17 @@
                 <a:spcPts val="5416"/>
               </a:lnSpc>
             </a:pPr>
-            <a:endParaRPr lang="en-US" sz="3868" spc="116">
-              <a:solidFill>
-                <a:srgbClr val="56678D"/>
-              </a:solidFill>
-              <a:latin typeface="29LT Riwaya"/>
-              <a:ea typeface="29LT Riwaya"/>
-              <a:cs typeface="29LT Riwaya"/>
-              <a:sym typeface="29LT Riwaya"/>
-            </a:endParaRPr>
-          </a:p>
-        </p:txBody>
-      </p:sp>
-      <p:sp>
-        <p:nvSpPr>
-          <p:cNvPr id="4" name="TextBox 4"/>
-          <p:cNvSpPr txBox="1"/>
+          </a:p>
+        </p:txBody>
+      </p:sp>
+      <p:sp>
+        <p:nvSpPr>
+          <p:cNvPr name="TextBox 4" id="4"/>
+          <p:cNvSpPr txBox="true"/>
           <p:nvPr/>
         </p:nvSpPr>
         <p:spPr>
-          <a:xfrm>
+          <a:xfrm rot="0">
             <a:off x="1028700" y="1121148"/>
             <a:ext cx="16230600" cy="1510745"/>
           </a:xfrm>
@@ -3821,12 +3824,12 @@
           </a:prstGeom>
         </p:spPr>
         <p:txBody>
-          <a:bodyPr lIns="0" tIns="0" rIns="0" bIns="0" rtlCol="0" anchor="t">
+          <a:bodyPr anchor="t" rtlCol="false" tIns="0" lIns="0" bIns="0" rIns="0">
             <a:spAutoFit/>
           </a:bodyPr>
           <a:lstStyle/>
           <a:p>
-            <a:pPr marL="0" lvl="0" indent="0" algn="ctr">
+            <a:pPr algn="ctr" marL="0" indent="0" lvl="0">
               <a:lnSpc>
                 <a:spcPts val="11755"/>
               </a:lnSpc>
@@ -3858,14 +3861,13 @@
 </file>
 
 <file path=ppt/slides/slide5.xml><?xml version="1.0" encoding="utf-8"?>
-<p:sld xmlns:a="http://schemas.openxmlformats.org/drawingml/2006/main" xmlns:r="http://schemas.openxmlformats.org/officeDocument/2006/relationships" xmlns:p="http://schemas.openxmlformats.org/presentationml/2006/main">
+<p:sld xmlns:p="http://schemas.openxmlformats.org/presentationml/2006/main" xmlns:a="http://schemas.openxmlformats.org/drawingml/2006/main" xmlns:r="http://schemas.openxmlformats.org/officeDocument/2006/relationships">
   <p:cSld>
     <p:bg>
       <p:bgPr>
         <a:solidFill>
           <a:srgbClr val="EAF0FF"/>
         </a:solidFill>
-        <a:effectLst/>
       </p:bgPr>
     </p:bg>
     <p:spTree>
@@ -3884,34 +3886,34 @@
       </p:grpSpPr>
       <p:sp>
         <p:nvSpPr>
-          <p:cNvPr id="2" name="Freeform 2"/>
+          <p:cNvPr name="Freeform 2" id="2"/>
           <p:cNvSpPr/>
           <p:nvPr/>
         </p:nvSpPr>
         <p:spPr>
-          <a:xfrm>
-            <a:off x="7924800" y="2723803"/>
-            <a:ext cx="9829800" cy="6763098"/>
+          <a:xfrm flipH="false" flipV="false" rot="0">
+            <a:off x="3208455" y="2690268"/>
+            <a:ext cx="13173094" cy="6689506"/>
           </a:xfrm>
           <a:custGeom>
             <a:avLst/>
             <a:gdLst/>
             <a:ahLst/>
             <a:cxnLst/>
-            <a:rect l="l" t="t" r="r" b="b"/>
+            <a:rect r="r" b="b" t="t" l="l"/>
             <a:pathLst>
-              <a:path w="8887393" h="4506377">
+              <a:path h="6689506" w="13173094">
                 <a:moveTo>
                   <a:pt x="0" y="0"/>
                 </a:moveTo>
                 <a:lnTo>
-                  <a:pt x="8887393" y="0"/>
+                  <a:pt x="13173094" y="0"/>
                 </a:lnTo>
                 <a:lnTo>
-                  <a:pt x="8887393" y="4506377"/>
+                  <a:pt x="13173094" y="6689507"/>
                 </a:lnTo>
                 <a:lnTo>
-                  <a:pt x="0" y="4506377"/>
+                  <a:pt x="0" y="6689507"/>
                 </a:lnTo>
                 <a:lnTo>
                   <a:pt x="0" y="0"/>
@@ -3923,152 +3925,19 @@
           <a:blipFill>
             <a:blip r:embed="rId2"/>
             <a:stretch>
-              <a:fillRect l="-12116" r="-15233"/>
+              <a:fillRect l="0" t="-1199" r="0" b="-1199"/>
             </a:stretch>
           </a:blipFill>
         </p:spPr>
       </p:sp>
       <p:sp>
         <p:nvSpPr>
-          <p:cNvPr id="3" name="TextBox 3"/>
-          <p:cNvSpPr txBox="1"/>
+          <p:cNvPr name="TextBox 3" id="3"/>
+          <p:cNvSpPr txBox="true"/>
           <p:nvPr/>
         </p:nvSpPr>
         <p:spPr>
-          <a:xfrm>
-            <a:off x="333021" y="2723802"/>
-            <a:ext cx="7418801" cy="6518414"/>
-          </a:xfrm>
-          <a:prstGeom prst="rect">
-            <a:avLst/>
-          </a:prstGeom>
-        </p:spPr>
-        <p:txBody>
-          <a:bodyPr lIns="0" tIns="0" rIns="0" bIns="0" rtlCol="0" anchor="t">
-            <a:spAutoFit/>
-          </a:bodyPr>
-          <a:lstStyle/>
-          <a:p>
-            <a:pPr marL="802554" lvl="1" indent="-401277" algn="l">
-              <a:lnSpc>
-                <a:spcPts val="5204"/>
-              </a:lnSpc>
-              <a:buFont typeface="Arial"/>
-              <a:buChar char="•"/>
-            </a:pPr>
-            <a:r>
-              <a:rPr lang="en-US" sz="3717" spc="111">
-                <a:solidFill>
-                  <a:srgbClr val="56678D"/>
-                </a:solidFill>
-                <a:latin typeface="29LT Riwaya"/>
-                <a:ea typeface="29LT Riwaya"/>
-                <a:cs typeface="29LT Riwaya"/>
-                <a:sym typeface="29LT Riwaya"/>
-              </a:rPr>
-              <a:t>mise en place, avec l’aide de camarades d’un autre groupe, un logiciel de versionning.</a:t>
-            </a:r>
-          </a:p>
-          <a:p>
-            <a:pPr algn="l">
-              <a:lnSpc>
-                <a:spcPts val="5204"/>
-              </a:lnSpc>
-            </a:pPr>
-            <a:endParaRPr lang="en-US" sz="3717" spc="111">
-              <a:solidFill>
-                <a:srgbClr val="56678D"/>
-              </a:solidFill>
-              <a:latin typeface="29LT Riwaya"/>
-              <a:ea typeface="29LT Riwaya"/>
-              <a:cs typeface="29LT Riwaya"/>
-              <a:sym typeface="29LT Riwaya"/>
-            </a:endParaRPr>
-          </a:p>
-          <a:p>
-            <a:pPr marL="802554" lvl="1" indent="-401277" algn="l">
-              <a:lnSpc>
-                <a:spcPts val="5204"/>
-              </a:lnSpc>
-              <a:buFont typeface="Arial"/>
-              <a:buChar char="•"/>
-            </a:pPr>
-            <a:r>
-              <a:rPr lang="en-US" sz="3717" spc="111">
-                <a:solidFill>
-                  <a:srgbClr val="56678D"/>
-                </a:solidFill>
-                <a:latin typeface="29LT Riwaya"/>
-                <a:ea typeface="29LT Riwaya"/>
-                <a:cs typeface="29LT Riwaya"/>
-                <a:sym typeface="29LT Riwaya"/>
-              </a:rPr>
-              <a:t>Il facilite la collaboration avec le reste du groupe InfoProd.</a:t>
-            </a:r>
-          </a:p>
-          <a:p>
-            <a:pPr algn="l">
-              <a:lnSpc>
-                <a:spcPts val="5204"/>
-              </a:lnSpc>
-            </a:pPr>
-            <a:endParaRPr lang="en-US" sz="3717" spc="111">
-              <a:solidFill>
-                <a:srgbClr val="56678D"/>
-              </a:solidFill>
-              <a:latin typeface="29LT Riwaya"/>
-              <a:ea typeface="29LT Riwaya"/>
-              <a:cs typeface="29LT Riwaya"/>
-              <a:sym typeface="29LT Riwaya"/>
-            </a:endParaRPr>
-          </a:p>
-          <a:p>
-            <a:pPr marL="802554" lvl="1" indent="-401277" algn="l">
-              <a:lnSpc>
-                <a:spcPts val="5204"/>
-              </a:lnSpc>
-              <a:buFont typeface="Arial"/>
-              <a:buChar char="•"/>
-            </a:pPr>
-            <a:r>
-              <a:rPr lang="en-US" sz="3717" spc="111">
-                <a:solidFill>
-                  <a:srgbClr val="56678D"/>
-                </a:solidFill>
-                <a:latin typeface="29LT Riwaya"/>
-                <a:ea typeface="29LT Riwaya"/>
-                <a:cs typeface="29LT Riwaya"/>
-                <a:sym typeface="29LT Riwaya"/>
-              </a:rPr>
-              <a:t>et outil m’a beaucoup aidé pour le partage de fichiers.</a:t>
-            </a:r>
-          </a:p>
-          <a:p>
-            <a:pPr algn="l">
-              <a:lnSpc>
-                <a:spcPts val="5204"/>
-              </a:lnSpc>
-            </a:pPr>
-            <a:endParaRPr lang="en-US" sz="3717" spc="111">
-              <a:solidFill>
-                <a:srgbClr val="56678D"/>
-              </a:solidFill>
-              <a:latin typeface="29LT Riwaya"/>
-              <a:ea typeface="29LT Riwaya"/>
-              <a:cs typeface="29LT Riwaya"/>
-              <a:sym typeface="29LT Riwaya"/>
-            </a:endParaRPr>
-          </a:p>
-        </p:txBody>
-      </p:sp>
-      <p:sp>
-        <p:nvSpPr>
-          <p:cNvPr id="4" name="TextBox 4"/>
-          <p:cNvSpPr txBox="1"/>
-          <p:nvPr/>
-        </p:nvSpPr>
-        <p:spPr>
-          <a:xfrm>
+          <a:xfrm rot="0">
             <a:off x="1028700" y="1121148"/>
             <a:ext cx="16230600" cy="1510745"/>
           </a:xfrm>
@@ -4077,12 +3946,12 @@
           </a:prstGeom>
         </p:spPr>
         <p:txBody>
-          <a:bodyPr lIns="0" tIns="0" rIns="0" bIns="0" rtlCol="0" anchor="t">
+          <a:bodyPr anchor="t" rtlCol="false" tIns="0" lIns="0" bIns="0" rIns="0">
             <a:spAutoFit/>
           </a:bodyPr>
           <a:lstStyle/>
           <a:p>
-            <a:pPr marL="0" lvl="0" indent="0" algn="ctr">
+            <a:pPr algn="ctr" marL="0" indent="0" lvl="0">
               <a:lnSpc>
                 <a:spcPts val="11755"/>
               </a:lnSpc>
@@ -4100,7 +3969,7 @@
                 <a:cs typeface="Boston Angel"/>
                 <a:sym typeface="Boston Angel"/>
               </a:rPr>
-              <a:t>Github Desktop</a:t>
+              <a:t>Diagramme de cas d'utilisation</a:t>
             </a:r>
           </a:p>
         </p:txBody>
@@ -4114,14 +3983,13 @@
 </file>
 
 <file path=ppt/slides/slide6.xml><?xml version="1.0" encoding="utf-8"?>
-<p:sld xmlns:a="http://schemas.openxmlformats.org/drawingml/2006/main" xmlns:r="http://schemas.openxmlformats.org/officeDocument/2006/relationships" xmlns:p="http://schemas.openxmlformats.org/presentationml/2006/main">
+<p:sld xmlns:p="http://schemas.openxmlformats.org/presentationml/2006/main" xmlns:a="http://schemas.openxmlformats.org/drawingml/2006/main" xmlns:r="http://schemas.openxmlformats.org/officeDocument/2006/relationships">
   <p:cSld>
     <p:bg>
       <p:bgPr>
         <a:solidFill>
           <a:srgbClr val="EAF0FF"/>
         </a:solidFill>
-        <a:effectLst/>
       </p:bgPr>
     </p:bg>
     <p:spTree>
@@ -4140,178 +4008,23 @@
       </p:grpSpPr>
       <p:sp>
         <p:nvSpPr>
-          <p:cNvPr id="2" name="Freeform 2"/>
+          <p:cNvPr name="Freeform 2" id="2"/>
           <p:cNvSpPr/>
           <p:nvPr/>
         </p:nvSpPr>
         <p:spPr>
-          <a:xfrm>
-            <a:off x="1295401" y="2857500"/>
-            <a:ext cx="15963900" cy="7010400"/>
+          <a:xfrm flipH="false" flipV="false" rot="0">
+            <a:off x="8239159" y="2924847"/>
+            <a:ext cx="9351545" cy="7004507"/>
           </a:xfrm>
           <a:custGeom>
             <a:avLst/>
             <a:gdLst/>
             <a:ahLst/>
             <a:cxnLst/>
-            <a:rect l="l" t="t" r="r" b="b"/>
+            <a:rect r="r" b="b" t="t" l="l"/>
             <a:pathLst>
-              <a:path w="12434821" h="6043279">
-                <a:moveTo>
-                  <a:pt x="0" y="0"/>
-                </a:moveTo>
-                <a:lnTo>
-                  <a:pt x="12434822" y="0"/>
-                </a:lnTo>
-                <a:lnTo>
-                  <a:pt x="12434822" y="6043279"/>
-                </a:lnTo>
-                <a:lnTo>
-                  <a:pt x="0" y="6043279"/>
-                </a:lnTo>
-                <a:lnTo>
-                  <a:pt x="0" y="0"/>
-                </a:lnTo>
-                <a:close/>
-              </a:path>
-            </a:pathLst>
-          </a:custGeom>
-          <a:blipFill>
-            <a:blip r:embed="rId2"/>
-            <a:stretch>
-              <a:fillRect l="-4087" r="-1135"/>
-            </a:stretch>
-          </a:blipFill>
-        </p:spPr>
-      </p:sp>
-      <p:sp>
-        <p:nvSpPr>
-          <p:cNvPr id="3" name="TextBox 3"/>
-          <p:cNvSpPr txBox="1"/>
-          <p:nvPr/>
-        </p:nvSpPr>
-        <p:spPr>
-          <a:xfrm>
-            <a:off x="0" y="3261174"/>
-            <a:ext cx="4965954" cy="635445"/>
-          </a:xfrm>
-          <a:prstGeom prst="rect">
-            <a:avLst/>
-          </a:prstGeom>
-        </p:spPr>
-        <p:txBody>
-          <a:bodyPr lIns="0" tIns="0" rIns="0" bIns="0" rtlCol="0" anchor="t">
-            <a:spAutoFit/>
-          </a:bodyPr>
-          <a:lstStyle/>
-          <a:p>
-            <a:pPr marL="802554" lvl="1" indent="-401277" algn="l">
-              <a:lnSpc>
-                <a:spcPts val="5204"/>
-              </a:lnSpc>
-              <a:buFont typeface="Arial"/>
-              <a:buChar char="•"/>
-            </a:pPr>
-            <a:endParaRPr/>
-          </a:p>
-        </p:txBody>
-      </p:sp>
-      <p:sp>
-        <p:nvSpPr>
-          <p:cNvPr id="4" name="TextBox 4"/>
-          <p:cNvSpPr txBox="1"/>
-          <p:nvPr/>
-        </p:nvSpPr>
-        <p:spPr>
-          <a:xfrm>
-            <a:off x="1028700" y="1121148"/>
-            <a:ext cx="16230600" cy="1510745"/>
-          </a:xfrm>
-          <a:prstGeom prst="rect">
-            <a:avLst/>
-          </a:prstGeom>
-        </p:spPr>
-        <p:txBody>
-          <a:bodyPr lIns="0" tIns="0" rIns="0" bIns="0" rtlCol="0" anchor="t">
-            <a:spAutoFit/>
-          </a:bodyPr>
-          <a:lstStyle/>
-          <a:p>
-            <a:pPr marL="0" lvl="0" indent="0" algn="ctr">
-              <a:lnSpc>
-                <a:spcPts val="11755"/>
-              </a:lnSpc>
-              <a:spcBef>
-                <a:spcPct val="0"/>
-              </a:spcBef>
-            </a:pPr>
-            <a:r>
-              <a:rPr lang="en-US" sz="8396" spc="419">
-                <a:solidFill>
-                  <a:srgbClr val="56678D"/>
-                </a:solidFill>
-                <a:latin typeface="Boston Angel"/>
-                <a:ea typeface="Boston Angel"/>
-                <a:cs typeface="Boston Angel"/>
-                <a:sym typeface="Boston Angel"/>
-              </a:rPr>
-              <a:t>Diagramme de cas d'utilisation</a:t>
-            </a:r>
-          </a:p>
-        </p:txBody>
-      </p:sp>
-    </p:spTree>
-  </p:cSld>
-  <p:clrMapOvr>
-    <a:masterClrMapping/>
-  </p:clrMapOvr>
-</p:sld>
-</file>
-
-<file path=ppt/slides/slide7.xml><?xml version="1.0" encoding="utf-8"?>
-<p:sld xmlns:a="http://schemas.openxmlformats.org/drawingml/2006/main" xmlns:r="http://schemas.openxmlformats.org/officeDocument/2006/relationships" xmlns:p="http://schemas.openxmlformats.org/presentationml/2006/main">
-  <p:cSld>
-    <p:bg>
-      <p:bgPr>
-        <a:solidFill>
-          <a:srgbClr val="EAF0FF"/>
-        </a:solidFill>
-        <a:effectLst/>
-      </p:bgPr>
-    </p:bg>
-    <p:spTree>
-      <p:nvGrpSpPr>
-        <p:cNvPr id="1" name=""/>
-        <p:cNvGrpSpPr/>
-        <p:nvPr/>
-      </p:nvGrpSpPr>
-      <p:grpSpPr>
-        <a:xfrm>
-          <a:off x="0" y="0"/>
-          <a:ext cx="0" cy="0"/>
-          <a:chOff x="0" y="0"/>
-          <a:chExt cx="0" cy="0"/>
-        </a:xfrm>
-      </p:grpSpPr>
-      <p:sp>
-        <p:nvSpPr>
-          <p:cNvPr id="2" name="Freeform 2"/>
-          <p:cNvSpPr/>
-          <p:nvPr/>
-        </p:nvSpPr>
-        <p:spPr>
-          <a:xfrm>
-            <a:off x="7919965" y="2924847"/>
-            <a:ext cx="9670739" cy="7004507"/>
-          </a:xfrm>
-          <a:custGeom>
-            <a:avLst/>
-            <a:gdLst/>
-            <a:ahLst/>
-            <a:cxnLst/>
-            <a:rect l="l" t="t" r="r" b="b"/>
-            <a:pathLst>
-              <a:path w="9351545" h="7004507">
+              <a:path h="7004507" w="9351545">
                 <a:moveTo>
                   <a:pt x="0" y="0"/>
                 </a:moveTo>
@@ -4334,19 +4047,19 @@
           <a:blipFill>
             <a:blip r:embed="rId2"/>
             <a:stretch>
-              <a:fillRect t="-65" b="-65"/>
+              <a:fillRect l="0" t="-65" r="0" b="-65"/>
             </a:stretch>
           </a:blipFill>
         </p:spPr>
       </p:sp>
       <p:sp>
         <p:nvSpPr>
-          <p:cNvPr id="3" name="TextBox 3"/>
-          <p:cNvSpPr txBox="1"/>
+          <p:cNvPr name="TextBox 3" id="3"/>
+          <p:cNvSpPr txBox="true"/>
           <p:nvPr/>
         </p:nvSpPr>
         <p:spPr>
-          <a:xfrm>
+          <a:xfrm rot="0">
             <a:off x="1028700" y="1121148"/>
             <a:ext cx="16230600" cy="1510745"/>
           </a:xfrm>
@@ -4355,12 +4068,12 @@
           </a:prstGeom>
         </p:spPr>
         <p:txBody>
-          <a:bodyPr lIns="0" tIns="0" rIns="0" bIns="0" rtlCol="0" anchor="t">
+          <a:bodyPr anchor="t" rtlCol="false" tIns="0" lIns="0" bIns="0" rIns="0">
             <a:spAutoFit/>
           </a:bodyPr>
           <a:lstStyle/>
           <a:p>
-            <a:pPr marL="0" lvl="0" indent="0" algn="ctr">
+            <a:pPr algn="ctr" marL="0" indent="0" lvl="0">
               <a:lnSpc>
                 <a:spcPts val="11755"/>
               </a:lnSpc>
@@ -4385,12 +4098,12 @@
       </p:sp>
       <p:sp>
         <p:nvSpPr>
-          <p:cNvPr id="4" name="TextBox 4"/>
-          <p:cNvSpPr txBox="1"/>
+          <p:cNvPr name="TextBox 4" id="4"/>
+          <p:cNvSpPr txBox="true"/>
           <p:nvPr/>
         </p:nvSpPr>
         <p:spPr>
-          <a:xfrm>
+          <a:xfrm rot="0">
             <a:off x="410435" y="3257396"/>
             <a:ext cx="7509530" cy="5441836"/>
           </a:xfrm>
@@ -4399,12 +4112,12 @@
           </a:prstGeom>
         </p:spPr>
         <p:txBody>
-          <a:bodyPr lIns="0" tIns="0" rIns="0" bIns="0" rtlCol="0" anchor="t">
+          <a:bodyPr anchor="t" rtlCol="false" tIns="0" lIns="0" bIns="0" rIns="0">
             <a:spAutoFit/>
           </a:bodyPr>
           <a:lstStyle/>
           <a:p>
-            <a:pPr marL="949961" lvl="1" indent="-474980" algn="ctr">
+            <a:pPr algn="ctr" marL="949961" indent="-474980" lvl="1">
               <a:lnSpc>
                 <a:spcPts val="6160"/>
               </a:lnSpc>
@@ -4425,7 +4138,7 @@
             </a:r>
           </a:p>
           <a:p>
-            <a:pPr marL="949961" lvl="1" indent="-474980" algn="ctr">
+            <a:pPr algn="ctr" marL="949961" indent="-474980" lvl="1">
               <a:lnSpc>
                 <a:spcPts val="6160"/>
               </a:lnSpc>
@@ -4446,7 +4159,7 @@
             </a:r>
           </a:p>
           <a:p>
-            <a:pPr marL="949961" lvl="1" indent="-474980" algn="ctr">
+            <a:pPr algn="ctr" marL="949961" indent="-474980" lvl="1">
               <a:lnSpc>
                 <a:spcPts val="6160"/>
               </a:lnSpc>
@@ -4464,6 +4177,200 @@
                 <a:sym typeface="Open Sans"/>
               </a:rPr>
               <a:t>L’écran LCD affiche enfin les valeurs</a:t>
+            </a:r>
+          </a:p>
+        </p:txBody>
+      </p:sp>
+    </p:spTree>
+  </p:cSld>
+  <p:clrMapOvr>
+    <a:masterClrMapping/>
+  </p:clrMapOvr>
+</p:sld>
+</file>
+
+<file path=ppt/slides/slide7.xml><?xml version="1.0" encoding="utf-8"?>
+<p:sld xmlns:p="http://schemas.openxmlformats.org/presentationml/2006/main" xmlns:a="http://schemas.openxmlformats.org/drawingml/2006/main">
+  <p:cSld>
+    <p:bg>
+      <p:bgPr>
+        <a:solidFill>
+          <a:srgbClr val="EAF0FF"/>
+        </a:solidFill>
+      </p:bgPr>
+    </p:bg>
+    <p:spTree>
+      <p:nvGrpSpPr>
+        <p:cNvPr id="1" name=""/>
+        <p:cNvGrpSpPr/>
+        <p:nvPr/>
+      </p:nvGrpSpPr>
+      <p:grpSpPr>
+        <a:xfrm>
+          <a:off x="0" y="0"/>
+          <a:ext cx="0" cy="0"/>
+          <a:chOff x="0" y="0"/>
+          <a:chExt cx="0" cy="0"/>
+        </a:xfrm>
+      </p:grpSpPr>
+      <p:sp>
+        <p:nvSpPr>
+          <p:cNvPr name="TextBox 2" id="2"/>
+          <p:cNvSpPr txBox="true"/>
+          <p:nvPr/>
+        </p:nvSpPr>
+        <p:spPr>
+          <a:xfrm rot="0">
+            <a:off x="333021" y="2723802"/>
+            <a:ext cx="7418801" cy="6518414"/>
+          </a:xfrm>
+          <a:prstGeom prst="rect">
+            <a:avLst/>
+          </a:prstGeom>
+        </p:spPr>
+        <p:txBody>
+          <a:bodyPr anchor="t" rtlCol="false" tIns="0" lIns="0" bIns="0" rIns="0">
+            <a:spAutoFit/>
+          </a:bodyPr>
+          <a:lstStyle/>
+          <a:p>
+            <a:pPr algn="l" marL="802554" indent="-401277" lvl="1">
+              <a:lnSpc>
+                <a:spcPts val="5204"/>
+              </a:lnSpc>
+              <a:buFont typeface="Arial"/>
+              <a:buChar char="•"/>
+            </a:pPr>
+            <a:r>
+              <a:rPr lang="en-US" sz="3717" spc="111">
+                <a:solidFill>
+                  <a:srgbClr val="56678D"/>
+                </a:solidFill>
+                <a:latin typeface="29LT Riwaya"/>
+                <a:ea typeface="29LT Riwaya"/>
+                <a:cs typeface="29LT Riwaya"/>
+                <a:sym typeface="29LT Riwaya"/>
+              </a:rPr>
+              <a:t>mise en place, avec l’aide de camarades d’un autre groupe, un logiciel de versionning.</a:t>
+            </a:r>
+          </a:p>
+          <a:p>
+            <a:pPr algn="l">
+              <a:lnSpc>
+                <a:spcPts val="5204"/>
+              </a:lnSpc>
+            </a:pPr>
+          </a:p>
+          <a:p>
+            <a:pPr algn="l" marL="802554" indent="-401277" lvl="1">
+              <a:lnSpc>
+                <a:spcPts val="5204"/>
+              </a:lnSpc>
+              <a:buFont typeface="Arial"/>
+              <a:buChar char="•"/>
+            </a:pPr>
+            <a:r>
+              <a:rPr lang="en-US" sz="3717" spc="111">
+                <a:solidFill>
+                  <a:srgbClr val="56678D"/>
+                </a:solidFill>
+                <a:latin typeface="29LT Riwaya"/>
+                <a:ea typeface="29LT Riwaya"/>
+                <a:cs typeface="29LT Riwaya"/>
+                <a:sym typeface="29LT Riwaya"/>
+              </a:rPr>
+              <a:t>I</a:t>
+            </a:r>
+            <a:r>
+              <a:rPr lang="en-US" sz="3717" spc="111">
+                <a:solidFill>
+                  <a:srgbClr val="56678D"/>
+                </a:solidFill>
+                <a:latin typeface="29LT Riwaya"/>
+                <a:ea typeface="29LT Riwaya"/>
+                <a:cs typeface="29LT Riwaya"/>
+                <a:sym typeface="29LT Riwaya"/>
+              </a:rPr>
+              <a:t>l facilite la collaboration avec le reste du groupe InfoProd.</a:t>
+            </a:r>
+          </a:p>
+          <a:p>
+            <a:pPr algn="l">
+              <a:lnSpc>
+                <a:spcPts val="5204"/>
+              </a:lnSpc>
+            </a:pPr>
+          </a:p>
+          <a:p>
+            <a:pPr algn="l" marL="802554" indent="-401277" lvl="1">
+              <a:lnSpc>
+                <a:spcPts val="5204"/>
+              </a:lnSpc>
+              <a:buFont typeface="Arial"/>
+              <a:buChar char="•"/>
+            </a:pPr>
+            <a:r>
+              <a:rPr lang="en-US" sz="3717" spc="111">
+                <a:solidFill>
+                  <a:srgbClr val="56678D"/>
+                </a:solidFill>
+                <a:latin typeface="29LT Riwaya"/>
+                <a:ea typeface="29LT Riwaya"/>
+                <a:cs typeface="29LT Riwaya"/>
+                <a:sym typeface="29LT Riwaya"/>
+              </a:rPr>
+              <a:t>et outil m’a beaucoup aidé pour le partage de fichiers.</a:t>
+            </a:r>
+          </a:p>
+          <a:p>
+            <a:pPr algn="l">
+              <a:lnSpc>
+                <a:spcPts val="5204"/>
+              </a:lnSpc>
+            </a:pPr>
+          </a:p>
+        </p:txBody>
+      </p:sp>
+      <p:sp>
+        <p:nvSpPr>
+          <p:cNvPr name="TextBox 3" id="3"/>
+          <p:cNvSpPr txBox="true"/>
+          <p:nvPr/>
+        </p:nvSpPr>
+        <p:spPr>
+          <a:xfrm rot="0">
+            <a:off x="1028700" y="1121148"/>
+            <a:ext cx="16230600" cy="1510745"/>
+          </a:xfrm>
+          <a:prstGeom prst="rect">
+            <a:avLst/>
+          </a:prstGeom>
+        </p:spPr>
+        <p:txBody>
+          <a:bodyPr anchor="t" rtlCol="false" tIns="0" lIns="0" bIns="0" rIns="0">
+            <a:spAutoFit/>
+          </a:bodyPr>
+          <a:lstStyle/>
+          <a:p>
+            <a:pPr algn="ctr" marL="0" indent="0" lvl="0">
+              <a:lnSpc>
+                <a:spcPts val="11755"/>
+              </a:lnSpc>
+              <a:spcBef>
+                <a:spcPct val="0"/>
+              </a:spcBef>
+            </a:pPr>
+            <a:r>
+              <a:rPr lang="en-US" sz="8396" spc="419">
+                <a:solidFill>
+                  <a:srgbClr val="56678D"/>
+                </a:solidFill>
+                <a:latin typeface="Boston Angel"/>
+                <a:ea typeface="Boston Angel"/>
+                <a:cs typeface="Boston Angel"/>
+                <a:sym typeface="Boston Angel"/>
+              </a:rPr>
+              <a:t>Github Desktop</a:t>
             </a:r>
           </a:p>
         </p:txBody>

</xml_diff>